<commit_message>
feat: rename presentation to Fleet Cost Intelligence Dashboard
</commit_message>
<xml_diff>
--- a/WEEK_7/Day_4/Fleet Cost Intelligence Dashboard.pptx
+++ b/WEEK_7/Day_4/Fleet Cost Intelligence Dashboard.pptx
@@ -124,6 +124,7 @@
 <p1510:revInfo xmlns:a="http://schemas.openxmlformats.org/drawingml/2006/main" xmlns:r="http://schemas.openxmlformats.org/officeDocument/2006/relationships" xmlns:p1510="http://schemas.microsoft.com/office/powerpoint/2015/10/main">
   <p1510:revLst>
     <p1510:client id="{369E08BA-E278-48BF-97EA-782A937E01AE}" v="5" dt="2026-03-23T01:10:03.190"/>
+    <p1510:client id="{478FEE5B-2301-4C25-9831-4B330491C665}" v="57" dt="2026-03-23T11:17:56.594"/>
     <p1510:client id="{5C600284-D709-4CE3-ABA9-341E811AB9FD}" v="2" dt="2026-03-23T01:29:06.477"/>
     <p1510:client id="{97F45E18-DD8C-4C91-9967-8A7036F04FBD}" v="149" dt="2026-03-23T00:04:55.508"/>
   </p1510:revLst>
@@ -494,7 +495,7 @@
           </a:lstStyle>
           <a:p>
             <a:fld id="{B5B42377-916F-492A-9E83-DB42C8A9C9AA}" type="datetimeFigureOut">
-              <a:t>3/22/2026</a:t>
+              <a:t>3/23/2026</a:t>
             </a:fld>
             <a:endParaRPr lang="en-US"/>
           </a:p>
@@ -1413,7 +1414,7 @@
           <a:p>
             <a:fld id="{F7021451-1387-4CA6-816F-3879F97B5CBC}" type="slidenum">
               <a:rPr lang="en-US"/>
-              <a:t>9</a:t>
+              <a:t>8</a:t>
             </a:fld>
             <a:endParaRPr lang="en-US"/>
           </a:p>
@@ -2011,26 +2012,12 @@
               <a:buNone/>
             </a:pPr>
             <a:r>
-              <a:rPr lang="en-US" sz="1300" dirty="0">
+              <a:rPr lang="en-US" sz="1300">
                 <a:solidFill>
                   <a:srgbClr val="8B949E"/>
                 </a:solidFill>
               </a:rPr>
-              <a:t>AI-powered fuel anomaly detection for regional haulage SMEs</a:t>
-            </a:r>
-            <a:endParaRPr lang="en-US" sz="1300" dirty="0"/>
-          </a:p>
-          <a:p>
-            <a:pPr marL="0" indent="0">
-              <a:buNone/>
-            </a:pPr>
-            <a:r>
-              <a:rPr lang="en-US" sz="1300" dirty="0">
-                <a:solidFill>
-                  <a:srgbClr val="8B949E"/>
-                </a:solidFill>
-              </a:rPr>
-              <a:t>Meeting preparation for Chleo — March 2026</a:t>
+              <a:t>AI-powered fuel anomaly detection for regional haulage SME</a:t>
             </a:r>
             <a:endParaRPr lang="en-US" sz="1300" dirty="0"/>
           </a:p>
@@ -2233,12 +2220,12 @@
               <a:buNone/>
             </a:pPr>
             <a:r>
-              <a:rPr lang="en-US" sz="2200" b="1" dirty="0">
+              <a:rPr lang="en-US" sz="2200" b="1">
                 <a:solidFill>
                   <a:srgbClr val="FFFFFF"/>
                 </a:solidFill>
               </a:rPr>
-              <a:t>€900k</a:t>
+              <a:t>€850k</a:t>
             </a:r>
             <a:endParaRPr lang="en-US" sz="2200" dirty="0"/>
           </a:p>
@@ -2794,18 +2781,53 @@
           <a:bodyPr wrap="square" lIns="0" tIns="0" rIns="0" bIns="0" rtlCol="0" anchor="ctr"/>
           <a:lstStyle/>
           <a:p>
-            <a:pPr marL="0" indent="0">
-              <a:buNone/>
-            </a:pPr>
             <a:r>
               <a:rPr lang="en-US" sz="1000" dirty="0">
                 <a:solidFill>
                   <a:srgbClr val="8B949E"/>
                 </a:solidFill>
               </a:rPr>
-              <a:t>Pedro Biain  |  IronHack AI Bootcamp  |  Week 7</a:t>
-            </a:r>
-            <a:endParaRPr lang="en-US" sz="1000" dirty="0"/>
+              <a:t>Pedro </a:t>
+            </a:r>
+            <a:r>
+              <a:rPr lang="en-US" sz="1000" dirty="0" err="1">
+                <a:solidFill>
+                  <a:srgbClr val="8B949E"/>
+                </a:solidFill>
+              </a:rPr>
+              <a:t>Biain</a:t>
+            </a:r>
+            <a:r>
+              <a:rPr lang="en-US" sz="1000" dirty="0">
+                <a:solidFill>
+                  <a:srgbClr val="8B949E"/>
+                </a:solidFill>
+              </a:rPr>
+              <a:t>  -  Silver Trush </a:t>
+            </a:r>
+            <a:r>
+              <a:rPr lang="en-US" sz="1000" dirty="0" err="1">
+                <a:solidFill>
+                  <a:srgbClr val="8B949E"/>
+                </a:solidFill>
+              </a:rPr>
+              <a:t>Consultin</a:t>
+            </a:r>
+            <a:r>
+              <a:rPr lang="en-US" sz="1000" dirty="0">
+                <a:solidFill>
+                  <a:srgbClr val="8B949E"/>
+                </a:solidFill>
+              </a:rPr>
+              <a:t>g</a:t>
+            </a:r>
+            <a:endParaRPr lang="en-US" sz="1000" dirty="0">
+              <a:solidFill>
+                <a:srgbClr val="8B949E"/>
+              </a:solidFill>
+              <a:ea typeface="Calibri"/>
+              <a:cs typeface="Calibri"/>
+            </a:endParaRPr>
           </a:p>
         </p:txBody>
       </p:sp>
@@ -4078,42 +4100,6 @@
           </a:ln>
         </p:spPr>
       </p:sp>
-      <p:sp>
-        <p:nvSpPr>
-          <p:cNvPr id="26" name="Text 24"/>
-          <p:cNvSpPr/>
-          <p:nvPr/>
-        </p:nvSpPr>
-        <p:spPr>
-          <a:xfrm>
-            <a:off x="640080" y="4315968"/>
-            <a:ext cx="7863840" cy="457200"/>
-          </a:xfrm>
-          <a:prstGeom prst="rect">
-            <a:avLst/>
-          </a:prstGeom>
-          <a:noFill/>
-          <a:ln/>
-        </p:spPr>
-        <p:txBody>
-          <a:bodyPr wrap="square" lIns="0" tIns="0" rIns="0" bIns="0" rtlCol="0" anchor="ctr"/>
-          <a:lstStyle/>
-          <a:p>
-            <a:pPr marL="0" indent="0">
-              <a:buNone/>
-            </a:pPr>
-            <a:r>
-              <a:rPr lang="en-US" sz="1300" i="1" dirty="0">
-                <a:solidFill>
-                  <a:srgbClr val="C9D1D9"/>
-                </a:solidFill>
-              </a:rPr>
-              <a:t>"AI is not transparent. I don't know what it does or how to trust it."  — Chleo</a:t>
-            </a:r>
-            <a:endParaRPr lang="en-US" sz="1300" dirty="0"/>
-          </a:p>
-        </p:txBody>
-      </p:sp>
     </p:spTree>
   </p:cSld>
   <p:clrMapOvr>
@@ -5252,7 +5238,7 @@
           <p:cNvPr id="16" name="Picture 15" descr="A screenshot of a graph&#10;&#10;AI-generated content may be incorrect.">
             <a:extLst>
               <a:ext uri="{FF2B5EF4-FFF2-40B4-BE49-F238E27FC236}">
-                <a16:creationId xmlns:a16="http://schemas.microsoft.com/office/drawing/2014/main" id="{780F2CDC-D483-DE7E-3405-1B80FEF475A7}"/>
+                <a16:creationId xmlns:a16="http://schemas.microsoft.com/office/drawing/2014/main" id="{8C97C383-AEEF-407A-FAA7-B97D23245E26}"/>
               </a:ext>
             </a:extLst>
           </p:cNvPr>
@@ -5269,8 +5255,8 @@
         </p:blipFill>
         <p:spPr>
           <a:xfrm>
-            <a:off x="183312" y="1780271"/>
-            <a:ext cx="6038491" cy="2866138"/>
+            <a:off x="409754" y="1495339"/>
+            <a:ext cx="5736567" cy="3134075"/>
           </a:xfrm>
           <a:prstGeom prst="rect">
             <a:avLst/>

</xml_diff>